<commit_message>
Clarify pilot cache policy and enlarge slide results
</commit_message>
<xml_diff>
--- a/CS764_RAG_Security_Presentation_Final.pptx
+++ b/CS764_RAG_Security_Presentation_Final.pptx
@@ -2,24 +2,24 @@
 <file path=ppt/presentation.xml><?xml version="1.0" encoding="utf-8"?>
 <p:presentation xmlns:p="http://schemas.openxmlformats.org/presentationml/2006/main">
   <p:sldMasterIdLst>
-    <p:sldMasterId xmlns:r="http://schemas.openxmlformats.org/officeDocument/2006/relationships" id="2147483648" r:id="Reecb4e7362484d29"/>
+    <p:sldMasterId xmlns:r="http://schemas.openxmlformats.org/officeDocument/2006/relationships" id="2147483648" r:id="Rafd23b999acb4d88"/>
   </p:sldMasterIdLst>
   <p:notesMasterIdLst>
-    <p:notesMasterId xmlns:r="http://schemas.openxmlformats.org/officeDocument/2006/relationships" r:id="R80b73154495148b4"/>
+    <p:notesMasterId xmlns:r="http://schemas.openxmlformats.org/officeDocument/2006/relationships" r:id="R05c28f32acb345ae"/>
   </p:notesMasterIdLst>
   <p:sldIdLst>
-    <p:sldId xmlns:r="http://schemas.openxmlformats.org/officeDocument/2006/relationships" id="256" r:id="Rc4159ab3fdf04e26"/>
-    <p:sldId xmlns:r="http://schemas.openxmlformats.org/officeDocument/2006/relationships" id="257" r:id="R161157dbca2d40cc"/>
-    <p:sldId xmlns:r="http://schemas.openxmlformats.org/officeDocument/2006/relationships" id="258" r:id="Rf896ece94c8d4358"/>
-    <p:sldId xmlns:r="http://schemas.openxmlformats.org/officeDocument/2006/relationships" id="259" r:id="Rc2191144b1bf45d1"/>
-    <p:sldId xmlns:r="http://schemas.openxmlformats.org/officeDocument/2006/relationships" id="260" r:id="R623bebc574454d11"/>
-    <p:sldId xmlns:r="http://schemas.openxmlformats.org/officeDocument/2006/relationships" id="261" r:id="Rf835b82a4ede43d7"/>
-    <p:sldId xmlns:r="http://schemas.openxmlformats.org/officeDocument/2006/relationships" id="262" r:id="R7fd4183d0250408a"/>
-    <p:sldId xmlns:r="http://schemas.openxmlformats.org/officeDocument/2006/relationships" id="263" r:id="R8eea983a2bdb4948"/>
-    <p:sldId xmlns:r="http://schemas.openxmlformats.org/officeDocument/2006/relationships" id="264" r:id="R92485e327fa44121"/>
-    <p:sldId xmlns:r="http://schemas.openxmlformats.org/officeDocument/2006/relationships" id="265" r:id="R9b7172dc6a4a4e1a"/>
-    <p:sldId xmlns:r="http://schemas.openxmlformats.org/officeDocument/2006/relationships" id="266" r:id="Rfb40167c212549d3"/>
-    <p:sldId xmlns:r="http://schemas.openxmlformats.org/officeDocument/2006/relationships" id="267" r:id="R059ae4f31e7f4883"/>
+    <p:sldId xmlns:r="http://schemas.openxmlformats.org/officeDocument/2006/relationships" id="256" r:id="Rae0625a4c32f465f"/>
+    <p:sldId xmlns:r="http://schemas.openxmlformats.org/officeDocument/2006/relationships" id="257" r:id="R8beb7d07aa154f6f"/>
+    <p:sldId xmlns:r="http://schemas.openxmlformats.org/officeDocument/2006/relationships" id="258" r:id="Rd76650c83b0c4b18"/>
+    <p:sldId xmlns:r="http://schemas.openxmlformats.org/officeDocument/2006/relationships" id="259" r:id="R1a032e2566e649d0"/>
+    <p:sldId xmlns:r="http://schemas.openxmlformats.org/officeDocument/2006/relationships" id="260" r:id="Rd83f91344f434a23"/>
+    <p:sldId xmlns:r="http://schemas.openxmlformats.org/officeDocument/2006/relationships" id="261" r:id="Re3198a759945405d"/>
+    <p:sldId xmlns:r="http://schemas.openxmlformats.org/officeDocument/2006/relationships" id="262" r:id="Rc4c247e70fe64ba6"/>
+    <p:sldId xmlns:r="http://schemas.openxmlformats.org/officeDocument/2006/relationships" id="263" r:id="R4aaa7a73b8844dc7"/>
+    <p:sldId xmlns:r="http://schemas.openxmlformats.org/officeDocument/2006/relationships" id="264" r:id="R6a4f355bb24844f1"/>
+    <p:sldId xmlns:r="http://schemas.openxmlformats.org/officeDocument/2006/relationships" id="265" r:id="R60c7682ac53e480c"/>
+    <p:sldId xmlns:r="http://schemas.openxmlformats.org/officeDocument/2006/relationships" id="266" r:id="Rcc16b7a60440486f"/>
+    <p:sldId xmlns:r="http://schemas.openxmlformats.org/officeDocument/2006/relationships" id="267" r:id="Rc29ba62e1b5c44c1"/>
   </p:sldIdLst>
   <p:sldSz cx="12192000" cy="6858000"/>
   <p:notesSz cx="6858000" cy="9144000"/>
@@ -463,7 +463,7 @@
           </a:p>
           <a:p xmlns:a="http://schemas.openxmlformats.org/drawingml/2006/main">
             <a:r>
-              <a:t>Our project examines instructions hidden in retrieved evidence. We built a two-signal passage gate and evaluated both detection and actual RAG answers. The revised experiments broaden the source and attack crossing and add an external classifier. The most important new finding is a failure: a gate that retains ordinary emails can still reject legitimate instructions.</a:t>
+              <a:t>Our project examines instructions hidden in retrieved evidence. We built a two-signal passage gate and evaluated both detection and actual RAG answers. The expanded experiments broaden the source and attack crossing and add an external classifier. The most important new finding is a failure: a gate that retains ordinary emails can still reject legitimate instructions.</a:t>
             </a:r>
           </a:p>
           <a:p xmlns:a="http://schemas.openxmlformats.org/drawingml/2006/main">
@@ -1183,7 +1183,7 @@
           </a:p>
           <a:p xmlns:a="http://schemas.openxmlformats.org/drawingml/2006/main">
             <a:r>
-              <a:t>The ROC and precision-recall plots show score ranking across the same held-out passages. At the chosen operating points, the combination detects seventy-four of one hundred eleven attacks, rules sixty-three and the original probe twenty-two. All retain the original clean emails. The external DeBERTa wrapper has an AUROC below point five and rejects most clean emails, so we explicitly audited its use rather than treating that result as an ordinary ranking. Mixed-window training improves the probe's AUROC but reduces recall at its validation-selected threshold. Curves, fixed thresholds and benign transfer answer different questions. Our second half connects those detector behaviours to actual answers and the diagnostic failures.</a:t>
+              <a:t>The ROC and precision-recall plots show score ranking across the same held-out passages. At the chosen operating points, the combination detects seventy-four of one hundred eleven attacks, rules sixty-three and the original probe twenty-two. The three local detectors retain the original clean emails. The external DeBERTa wrapper has an AUROC below point five and rejects most clean emails, so we explicitly audited its use rather than treating that result as an ordinary ranking. Mixed-window training improves the probe's AUROC but reduces recall at its validation-selected threshold. Curves, fixed thresholds and benign transfer answer different questions. Our second half connects those detector behaviours to actual answers and the diagnostic failures.</a:t>
             </a:r>
           </a:p>
           <a:p xmlns:a="http://schemas.openxmlformats.org/drawingml/2006/main">
@@ -1510,7 +1510,7 @@
           <p:cNvPr id="3" name="Title">
             <a:extLst xmlns:a="http://schemas.openxmlformats.org/drawingml/2006/main">
               <a:ext uri="{FF2B5EF4-FFF2-40B4-BE49-F238E27FC236}">
-                <a16:creationId xmlns:a16="http://schemas.microsoft.com/office/drawing/2014/main" id="{614A38AA-2762-49E3-B9D8-79DD9EF7C08D}"/>
+                <a16:creationId xmlns:a16="http://schemas.microsoft.com/office/drawing/2014/main" id="{55382E5C-662B-476F-BB0F-5366C33251BC}"/>
               </a:ext>
             </a:extLst>
           </p:cNvPr>
@@ -1739,7 +1739,7 @@
           <p:cNvPr id="2" name="Subtitle">
             <a:extLst xmlns:a="http://schemas.openxmlformats.org/drawingml/2006/main">
               <a:ext uri="{FF2B5EF4-FFF2-40B4-BE49-F238E27FC236}">
-                <a16:creationId xmlns:a16="http://schemas.microsoft.com/office/drawing/2014/main" id="{EFC2968C-EBE9-44A9-8624-ED1D0A3D2359}"/>
+                <a16:creationId xmlns:a16="http://schemas.microsoft.com/office/drawing/2014/main" id="{A1A7724C-10A4-4D22-AB41-316D7F8A7131}"/>
               </a:ext>
             </a:extLst>
           </p:cNvPr>
@@ -1985,7 +1985,7 @@
           <p:cNvPr id="2" name="Section title">
             <a:extLst xmlns:a="http://schemas.openxmlformats.org/drawingml/2006/main">
               <a:ext uri="{FF2B5EF4-FFF2-40B4-BE49-F238E27FC236}">
-                <a16:creationId xmlns:a16="http://schemas.microsoft.com/office/drawing/2014/main" id="{7BAF481B-3C5D-4BAB-99B9-9EBB1DB9E195}"/>
+                <a16:creationId xmlns:a16="http://schemas.microsoft.com/office/drawing/2014/main" id="{54838B2F-CB9E-496C-8360-D5CD84E529EC}"/>
               </a:ext>
             </a:extLst>
           </p:cNvPr>
@@ -2231,7 +2231,7 @@
           <p:cNvPr id="3" name="Title">
             <a:extLst xmlns:a="http://schemas.openxmlformats.org/drawingml/2006/main">
               <a:ext uri="{FF2B5EF4-FFF2-40B4-BE49-F238E27FC236}">
-                <a16:creationId xmlns:a16="http://schemas.microsoft.com/office/drawing/2014/main" id="{6620E288-DEB6-47B0-8252-78F1E16F6806}"/>
+                <a16:creationId xmlns:a16="http://schemas.microsoft.com/office/drawing/2014/main" id="{A3B62053-6FEA-4E69-9650-A0387C1F7800}"/>
               </a:ext>
             </a:extLst>
           </p:cNvPr>
@@ -2460,7 +2460,7 @@
           <p:cNvPr id="2" name="Body">
             <a:extLst xmlns:a="http://schemas.openxmlformats.org/drawingml/2006/main">
               <a:ext uri="{FF2B5EF4-FFF2-40B4-BE49-F238E27FC236}">
-                <a16:creationId xmlns:a16="http://schemas.microsoft.com/office/drawing/2014/main" id="{A434D721-9103-47F1-94A6-5CB65339B5D1}"/>
+                <a16:creationId xmlns:a16="http://schemas.microsoft.com/office/drawing/2014/main" id="{04DA4BD6-F2E5-406E-99F0-9EEEBAF20CCD}"/>
               </a:ext>
             </a:extLst>
           </p:cNvPr>
@@ -2706,7 +2706,7 @@
           <p:cNvPr id="4" name="Title">
             <a:extLst xmlns:a="http://schemas.openxmlformats.org/drawingml/2006/main">
               <a:ext uri="{FF2B5EF4-FFF2-40B4-BE49-F238E27FC236}">
-                <a16:creationId xmlns:a16="http://schemas.microsoft.com/office/drawing/2014/main" id="{174B5707-E90E-4D17-9205-FF26D1EAAA0B}"/>
+                <a16:creationId xmlns:a16="http://schemas.microsoft.com/office/drawing/2014/main" id="{09937FD2-CBE7-45DD-A221-95EC4B41F0C4}"/>
               </a:ext>
             </a:extLst>
           </p:cNvPr>
@@ -2935,7 +2935,7 @@
           <p:cNvPr id="2" name="Left column">
             <a:extLst xmlns:a="http://schemas.openxmlformats.org/drawingml/2006/main">
               <a:ext uri="{FF2B5EF4-FFF2-40B4-BE49-F238E27FC236}">
-                <a16:creationId xmlns:a16="http://schemas.microsoft.com/office/drawing/2014/main" id="{BD440963-DF15-411C-8222-F63CDB512EE1}"/>
+                <a16:creationId xmlns:a16="http://schemas.microsoft.com/office/drawing/2014/main" id="{ED415F4B-26B1-4607-9BFB-CED9774C2A1E}"/>
               </a:ext>
             </a:extLst>
           </p:cNvPr>
@@ -3164,7 +3164,7 @@
           <p:cNvPr id="3" name="Right column">
             <a:extLst xmlns:a="http://schemas.openxmlformats.org/drawingml/2006/main">
               <a:ext uri="{FF2B5EF4-FFF2-40B4-BE49-F238E27FC236}">
-                <a16:creationId xmlns:a16="http://schemas.microsoft.com/office/drawing/2014/main" id="{47C09D02-C7BA-4A43-953D-7B36D1A8A131}"/>
+                <a16:creationId xmlns:a16="http://schemas.microsoft.com/office/drawing/2014/main" id="{8AF16AAB-C466-4B07-9B82-653D23C0EAF6}"/>
               </a:ext>
             </a:extLst>
           </p:cNvPr>
@@ -3410,7 +3410,7 @@
           <p:cNvPr id="3" name="Title">
             <a:extLst xmlns:a="http://schemas.openxmlformats.org/drawingml/2006/main">
               <a:ext uri="{FF2B5EF4-FFF2-40B4-BE49-F238E27FC236}">
-                <a16:creationId xmlns:a16="http://schemas.microsoft.com/office/drawing/2014/main" id="{C3A6A52F-E3A6-4979-9450-3BB5A996B539}"/>
+                <a16:creationId xmlns:a16="http://schemas.microsoft.com/office/drawing/2014/main" id="{A0478F29-0DE3-43F0-BEEE-4F876D7A7F08}"/>
               </a:ext>
             </a:extLst>
           </p:cNvPr>
@@ -3639,7 +3639,7 @@
           <p:cNvPr id="2" name="Left column">
             <a:extLst xmlns:a="http://schemas.openxmlformats.org/drawingml/2006/main">
               <a:ext uri="{FF2B5EF4-FFF2-40B4-BE49-F238E27FC236}">
-                <a16:creationId xmlns:a16="http://schemas.microsoft.com/office/drawing/2014/main" id="{62AF4A42-5F44-4FEC-9500-F8F5DEADCBAE}"/>
+                <a16:creationId xmlns:a16="http://schemas.microsoft.com/office/drawing/2014/main" id="{B17F20F3-A2D5-4583-9424-14E0F629F11F}"/>
               </a:ext>
             </a:extLst>
           </p:cNvPr>
@@ -3906,12 +3906,12 @@
   </p:cSld>
   <p:clrMap bg1="lt1" tx1="dk1" bg2="lt2" tx2="dk2" accent1="accent1" accent2="accent2" accent3="accent3" accent4="accent4" accent5="accent5" accent6="accent6" hlink="hlink" folHlink="folHlink"/>
   <p:sldLayoutIdLst>
-    <p:sldLayoutId xmlns:r="http://schemas.openxmlformats.org/officeDocument/2006/relationships" id="2147483649" r:id="R3da82a3184254c30"/>
-    <p:sldLayoutId xmlns:r="http://schemas.openxmlformats.org/officeDocument/2006/relationships" id="2147483650" r:id="R25c85c5f52954764"/>
-    <p:sldLayoutId xmlns:r="http://schemas.openxmlformats.org/officeDocument/2006/relationships" id="2147483651" r:id="Raecb1cb0fb434a48"/>
-    <p:sldLayoutId xmlns:r="http://schemas.openxmlformats.org/officeDocument/2006/relationships" id="2147483652" r:id="R7f808502d5974c6b"/>
-    <p:sldLayoutId xmlns:r="http://schemas.openxmlformats.org/officeDocument/2006/relationships" id="2147483653" r:id="R9def21c342994185"/>
-    <p:sldLayoutId xmlns:r="http://schemas.openxmlformats.org/officeDocument/2006/relationships" id="2147483654" r:id="R356376e1c3314837"/>
+    <p:sldLayoutId xmlns:r="http://schemas.openxmlformats.org/officeDocument/2006/relationships" id="2147483649" r:id="R278ea3dc901041df"/>
+    <p:sldLayoutId xmlns:r="http://schemas.openxmlformats.org/officeDocument/2006/relationships" id="2147483650" r:id="R4961760fe8524394"/>
+    <p:sldLayoutId xmlns:r="http://schemas.openxmlformats.org/officeDocument/2006/relationships" id="2147483651" r:id="R73c652f806b54a32"/>
+    <p:sldLayoutId xmlns:r="http://schemas.openxmlformats.org/officeDocument/2006/relationships" id="2147483652" r:id="R615ed086bd024261"/>
+    <p:sldLayoutId xmlns:r="http://schemas.openxmlformats.org/officeDocument/2006/relationships" id="2147483653" r:id="R2389101d337d4fa0"/>
+    <p:sldLayoutId xmlns:r="http://schemas.openxmlformats.org/officeDocument/2006/relationships" id="2147483654" r:id="Ra81c581b5daa49bf"/>
   </p:sldLayoutIdLst>
   <p:txStyles>
     <p:titleStyle>
@@ -4462,7 +4462,7 @@
           <p:cNvPr id="4" name="">
             <a:extLst xmlns:a="http://schemas.openxmlformats.org/drawingml/2006/main">
               <a:ext uri="{FF2B5EF4-FFF2-40B4-BE49-F238E27FC236}">
-                <a16:creationId xmlns:a16="http://schemas.microsoft.com/office/drawing/2014/main" id="{4F419F95-079D-4737-9738-BB5C3229CF61}"/>
+                <a16:creationId xmlns:a16="http://schemas.microsoft.com/office/drawing/2014/main" id="{01F8EEBF-D282-42D1-A7FB-90F2300DCF7A}"/>
               </a:ext>
             </a:extLst>
           </p:cNvPr>
@@ -4642,7 +4642,7 @@
           <p:cNvPr id="2" name="">
             <a:extLst xmlns:a="http://schemas.openxmlformats.org/drawingml/2006/main">
               <a:ext uri="{FF2B5EF4-FFF2-40B4-BE49-F238E27FC236}">
-                <a16:creationId xmlns:a16="http://schemas.microsoft.com/office/drawing/2014/main" id="{ECE4C719-C541-4E97-AF54-0E8B844BECBA}"/>
+                <a16:creationId xmlns:a16="http://schemas.microsoft.com/office/drawing/2014/main" id="{FC711911-A6D8-42E0-B48F-B5973F14FBA3}"/>
               </a:ext>
             </a:extLst>
           </p:cNvPr>
@@ -4799,7 +4799,7 @@
           <p:cNvPr id="3" name="">
             <a:extLst xmlns:a="http://schemas.openxmlformats.org/drawingml/2006/main">
               <a:ext uri="{FF2B5EF4-FFF2-40B4-BE49-F238E27FC236}">
-                <a16:creationId xmlns:a16="http://schemas.microsoft.com/office/drawing/2014/main" id="{46A70500-F94B-41B8-AB3F-8C6B7D4D9FCB}"/>
+                <a16:creationId xmlns:a16="http://schemas.microsoft.com/office/drawing/2014/main" id="{29A05813-1ECD-49BE-86FE-0561F2D2D62A}"/>
               </a:ext>
             </a:extLst>
           </p:cNvPr>
@@ -4977,7 +4977,7 @@
     </p:spTree>
     <p:extLst>
       <p:ext uri="{BB962C8B-B14F-4D97-AF65-F5344CB8AC3E}">
-        <p14:creationId xmlns:p14="http://schemas.microsoft.com/office/powerpoint/2010/main" val="1199366150"/>
+        <p14:creationId xmlns:p14="http://schemas.microsoft.com/office/powerpoint/2010/main" val="1782844148"/>
       </p:ext>
     </p:extLst>
   </p:cSld>
@@ -5008,7 +5008,7 @@
           <p:cNvPr id="6" name="">
             <a:extLst xmlns:a="http://schemas.openxmlformats.org/drawingml/2006/main">
               <a:ext uri="{FF2B5EF4-FFF2-40B4-BE49-F238E27FC236}">
-                <a16:creationId xmlns:a16="http://schemas.microsoft.com/office/drawing/2014/main" id="{7B9690EA-2D8F-4BF7-9A59-CD5780FE7543}"/>
+                <a16:creationId xmlns:a16="http://schemas.microsoft.com/office/drawing/2014/main" id="{6A1677AA-2601-4DB9-93FC-202B6E0A6B42}"/>
               </a:ext>
             </a:extLst>
           </p:cNvPr>
@@ -5165,7 +5165,7 @@
           <p:cNvPr id="2" name="">
             <a:extLst xmlns:a="http://schemas.openxmlformats.org/drawingml/2006/main">
               <a:ext uri="{FF2B5EF4-FFF2-40B4-BE49-F238E27FC236}">
-                <a16:creationId xmlns:a16="http://schemas.microsoft.com/office/drawing/2014/main" id="{EAF29F2F-54F7-4928-881E-C1B917185F48}"/>
+                <a16:creationId xmlns:a16="http://schemas.microsoft.com/office/drawing/2014/main" id="{79C831DA-B866-4DCE-A617-C6470DDB7178}"/>
               </a:ext>
             </a:extLst>
           </p:cNvPr>
@@ -5196,7 +5196,7 @@
           <p:cNvPr id="3" name="">
             <a:extLst xmlns:a="http://schemas.openxmlformats.org/drawingml/2006/main">
               <a:ext uri="{FF2B5EF4-FFF2-40B4-BE49-F238E27FC236}">
-                <a16:creationId xmlns:a16="http://schemas.microsoft.com/office/drawing/2014/main" id="{B7C6E1F7-FA38-47D0-A06D-682D8C450BD4}"/>
+                <a16:creationId xmlns:a16="http://schemas.microsoft.com/office/drawing/2014/main" id="{DC106F31-47CE-4496-BC84-02CC08AFBF24}"/>
               </a:ext>
             </a:extLst>
           </p:cNvPr>
@@ -5353,7 +5353,7 @@
           <p:cNvPr id="4" name="">
             <a:extLst xmlns:a="http://schemas.openxmlformats.org/drawingml/2006/main">
               <a:ext uri="{FF2B5EF4-FFF2-40B4-BE49-F238E27FC236}">
-                <a16:creationId xmlns:a16="http://schemas.microsoft.com/office/drawing/2014/main" id="{34A914C1-0EDE-4E71-AB6C-79BF5E870CFD}"/>
+                <a16:creationId xmlns:a16="http://schemas.microsoft.com/office/drawing/2014/main" id="{AAFF7315-A668-4761-8E06-55B9F58DC376}"/>
               </a:ext>
             </a:extLst>
           </p:cNvPr>
@@ -5793,7 +5793,7 @@
           <p:cNvPr id="5" name="">
             <a:extLst xmlns:a="http://schemas.openxmlformats.org/drawingml/2006/main">
               <a:ext uri="{FF2B5EF4-FFF2-40B4-BE49-F238E27FC236}">
-                <a16:creationId xmlns:a16="http://schemas.microsoft.com/office/drawing/2014/main" id="{4C9C5AA8-8862-4997-925B-E5B85D884B99}"/>
+                <a16:creationId xmlns:a16="http://schemas.microsoft.com/office/drawing/2014/main" id="{3C164139-450C-45A9-B3B7-EAF84E7B2AF0}"/>
               </a:ext>
             </a:extLst>
           </p:cNvPr>
@@ -5948,7 +5948,7 @@
     </p:spTree>
     <p:extLst>
       <p:ext uri="{BB962C8B-B14F-4D97-AF65-F5344CB8AC3E}">
-        <p14:creationId xmlns:p14="http://schemas.microsoft.com/office/powerpoint/2010/main" val="2087770779"/>
+        <p14:creationId xmlns:p14="http://schemas.microsoft.com/office/powerpoint/2010/main" val="869775254"/>
       </p:ext>
     </p:extLst>
   </p:cSld>
@@ -5979,7 +5979,7 @@
           <p:cNvPr id="9" name="">
             <a:extLst xmlns:a="http://schemas.openxmlformats.org/drawingml/2006/main">
               <a:ext uri="{FF2B5EF4-FFF2-40B4-BE49-F238E27FC236}">
-                <a16:creationId xmlns:a16="http://schemas.microsoft.com/office/drawing/2014/main" id="{8000570D-240B-42F1-85FD-438808FB109E}"/>
+                <a16:creationId xmlns:a16="http://schemas.microsoft.com/office/drawing/2014/main" id="{1DF20257-2B30-421B-A167-477667C2B9F8}"/>
               </a:ext>
             </a:extLst>
           </p:cNvPr>
@@ -6136,7 +6136,7 @@
           <p:cNvPr id="2" name="">
             <a:extLst xmlns:a="http://schemas.openxmlformats.org/drawingml/2006/main">
               <a:ext uri="{FF2B5EF4-FFF2-40B4-BE49-F238E27FC236}">
-                <a16:creationId xmlns:a16="http://schemas.microsoft.com/office/drawing/2014/main" id="{6688046A-0F1C-471C-B7D9-6CAE7A933C48}"/>
+                <a16:creationId xmlns:a16="http://schemas.microsoft.com/office/drawing/2014/main" id="{2B1F3C2A-7C5A-46CC-815A-F474D3B863D2}"/>
               </a:ext>
             </a:extLst>
           </p:cNvPr>
@@ -6167,7 +6167,7 @@
           <p:cNvPr id="3" name="">
             <a:extLst xmlns:a="http://schemas.openxmlformats.org/drawingml/2006/main">
               <a:ext uri="{FF2B5EF4-FFF2-40B4-BE49-F238E27FC236}">
-                <a16:creationId xmlns:a16="http://schemas.microsoft.com/office/drawing/2014/main" id="{A3B82446-8016-41AC-9972-FF9D6B05C543}"/>
+                <a16:creationId xmlns:a16="http://schemas.microsoft.com/office/drawing/2014/main" id="{2EDB3D93-FE04-4484-878B-5D383A14995F}"/>
               </a:ext>
             </a:extLst>
           </p:cNvPr>
@@ -6324,7 +6324,7 @@
           <p:cNvPr id="4" name="">
             <a:extLst xmlns:a="http://schemas.openxmlformats.org/drawingml/2006/main">
               <a:ext uri="{FF2B5EF4-FFF2-40B4-BE49-F238E27FC236}">
-                <a16:creationId xmlns:a16="http://schemas.microsoft.com/office/drawing/2014/main" id="{1213F80E-CB53-47BE-BB31-0935B951F279}"/>
+                <a16:creationId xmlns:a16="http://schemas.microsoft.com/office/drawing/2014/main" id="{BD7E1D47-BC84-45DF-B074-856B1789CA6D}"/>
               </a:ext>
             </a:extLst>
           </p:cNvPr>
@@ -6481,7 +6481,7 @@
           <p:cNvPr id="5" name="">
             <a:extLst xmlns:a="http://schemas.openxmlformats.org/drawingml/2006/main">
               <a:ext uri="{FF2B5EF4-FFF2-40B4-BE49-F238E27FC236}">
-                <a16:creationId xmlns:a16="http://schemas.microsoft.com/office/drawing/2014/main" id="{035D101A-A7DF-4393-BD1C-B047955F0D62}"/>
+                <a16:creationId xmlns:a16="http://schemas.microsoft.com/office/drawing/2014/main" id="{16EDFA39-5E52-4382-BF14-8F00DEFDE4C8}"/>
               </a:ext>
             </a:extLst>
           </p:cNvPr>
@@ -6684,7 +6684,7 @@
           <p:cNvPr id="6" name="">
             <a:extLst xmlns:a="http://schemas.openxmlformats.org/drawingml/2006/main">
               <a:ext uri="{FF2B5EF4-FFF2-40B4-BE49-F238E27FC236}">
-                <a16:creationId xmlns:a16="http://schemas.microsoft.com/office/drawing/2014/main" id="{ECA5A1F9-7055-43B7-B564-949D5C395881}"/>
+                <a16:creationId xmlns:a16="http://schemas.microsoft.com/office/drawing/2014/main" id="{7265CBD0-2AEA-48B5-929D-E327A56C84F0}"/>
               </a:ext>
             </a:extLst>
           </p:cNvPr>
@@ -6841,7 +6841,7 @@
           <p:cNvPr id="7" name="">
             <a:extLst xmlns:a="http://schemas.openxmlformats.org/drawingml/2006/main">
               <a:ext uri="{FF2B5EF4-FFF2-40B4-BE49-F238E27FC236}">
-                <a16:creationId xmlns:a16="http://schemas.microsoft.com/office/drawing/2014/main" id="{6F8F2D62-0360-49A4-B879-1BA69F2EB268}"/>
+                <a16:creationId xmlns:a16="http://schemas.microsoft.com/office/drawing/2014/main" id="{2ECE5DC3-C2CB-4295-9C77-1F731B75B9BA}"/>
               </a:ext>
             </a:extLst>
           </p:cNvPr>
@@ -7044,7 +7044,7 @@
           <p:cNvPr id="8" name="">
             <a:extLst xmlns:a="http://schemas.openxmlformats.org/drawingml/2006/main">
               <a:ext uri="{FF2B5EF4-FFF2-40B4-BE49-F238E27FC236}">
-                <a16:creationId xmlns:a16="http://schemas.microsoft.com/office/drawing/2014/main" id="{AADED3E8-1829-41D9-831D-DF5804E25C1D}"/>
+                <a16:creationId xmlns:a16="http://schemas.microsoft.com/office/drawing/2014/main" id="{935411BE-43C2-49D7-8F61-54A99DE5AF97}"/>
               </a:ext>
             </a:extLst>
           </p:cNvPr>
@@ -7199,7 +7199,7 @@
     </p:spTree>
     <p:extLst>
       <p:ext uri="{BB962C8B-B14F-4D97-AF65-F5344CB8AC3E}">
-        <p14:creationId xmlns:p14="http://schemas.microsoft.com/office/powerpoint/2010/main" val="1094085374"/>
+        <p14:creationId xmlns:p14="http://schemas.microsoft.com/office/powerpoint/2010/main" val="1932832731"/>
       </p:ext>
     </p:extLst>
   </p:cSld>
@@ -7230,7 +7230,7 @@
           <p:cNvPr id="7" name="">
             <a:extLst xmlns:a="http://schemas.openxmlformats.org/drawingml/2006/main">
               <a:ext uri="{FF2B5EF4-FFF2-40B4-BE49-F238E27FC236}">
-                <a16:creationId xmlns:a16="http://schemas.microsoft.com/office/drawing/2014/main" id="{E1EAD28F-ED46-4631-B5E3-79A1D0C910F0}"/>
+                <a16:creationId xmlns:a16="http://schemas.microsoft.com/office/drawing/2014/main" id="{3FCBFAB2-EA95-4C52-B33B-B3CE4BBE2993}"/>
               </a:ext>
             </a:extLst>
           </p:cNvPr>
@@ -7387,7 +7387,7 @@
           <p:cNvPr id="2" name="">
             <a:extLst xmlns:a="http://schemas.openxmlformats.org/drawingml/2006/main">
               <a:ext uri="{FF2B5EF4-FFF2-40B4-BE49-F238E27FC236}">
-                <a16:creationId xmlns:a16="http://schemas.microsoft.com/office/drawing/2014/main" id="{5BC882F6-BA6B-493B-95E3-08D2B97E99A1}"/>
+                <a16:creationId xmlns:a16="http://schemas.microsoft.com/office/drawing/2014/main" id="{B2300869-D2E5-46A2-8C85-EBBCBF905BE7}"/>
               </a:ext>
             </a:extLst>
           </p:cNvPr>
@@ -7418,7 +7418,7 @@
           <p:cNvPr id="3" name="">
             <a:extLst xmlns:a="http://schemas.openxmlformats.org/drawingml/2006/main">
               <a:ext uri="{FF2B5EF4-FFF2-40B4-BE49-F238E27FC236}">
-                <a16:creationId xmlns:a16="http://schemas.microsoft.com/office/drawing/2014/main" id="{4A3E2BAF-E755-4334-BA86-9679090E6969}"/>
+                <a16:creationId xmlns:a16="http://schemas.microsoft.com/office/drawing/2014/main" id="{E7ABED95-FB2C-41AD-9306-B4DE508FB174}"/>
               </a:ext>
             </a:extLst>
           </p:cNvPr>
@@ -7575,7 +7575,7 @@
           <p:cNvPr id="4" name="">
             <a:extLst xmlns:a="http://schemas.openxmlformats.org/drawingml/2006/main">
               <a:ext uri="{FF2B5EF4-FFF2-40B4-BE49-F238E27FC236}">
-                <a16:creationId xmlns:a16="http://schemas.microsoft.com/office/drawing/2014/main" id="{36044203-E39E-49AD-B3A0-CC2E40104CB2}"/>
+                <a16:creationId xmlns:a16="http://schemas.microsoft.com/office/drawing/2014/main" id="{A508E9E6-8D65-4678-9F8B-F214750BFA29}"/>
               </a:ext>
             </a:extLst>
           </p:cNvPr>
@@ -7732,7 +7732,7 @@
           <p:cNvPr id="5" name="">
             <a:extLst xmlns:a="http://schemas.openxmlformats.org/drawingml/2006/main">
               <a:ext uri="{FF2B5EF4-FFF2-40B4-BE49-F238E27FC236}">
-                <a16:creationId xmlns:a16="http://schemas.microsoft.com/office/drawing/2014/main" id="{D1D58BC0-DB4C-46C1-80CD-ED6DC60E18FD}"/>
+                <a16:creationId xmlns:a16="http://schemas.microsoft.com/office/drawing/2014/main" id="{A6B8940E-7F5A-4685-A9CB-2CB905A4E856}"/>
               </a:ext>
             </a:extLst>
           </p:cNvPr>
@@ -7889,7 +7889,7 @@
           <p:cNvPr id="6" name="">
             <a:extLst xmlns:a="http://schemas.openxmlformats.org/drawingml/2006/main">
               <a:ext uri="{FF2B5EF4-FFF2-40B4-BE49-F238E27FC236}">
-                <a16:creationId xmlns:a16="http://schemas.microsoft.com/office/drawing/2014/main" id="{E5DB2B22-C5DA-4D09-80AA-E0CB4C3ADA8C}"/>
+                <a16:creationId xmlns:a16="http://schemas.microsoft.com/office/drawing/2014/main" id="{4F0C62AC-3BB4-4FF2-9177-B6FA1C21A04A}"/>
               </a:ext>
             </a:extLst>
           </p:cNvPr>
@@ -8044,7 +8044,7 @@
     </p:spTree>
     <p:extLst>
       <p:ext uri="{BB962C8B-B14F-4D97-AF65-F5344CB8AC3E}">
-        <p14:creationId xmlns:p14="http://schemas.microsoft.com/office/powerpoint/2010/main" val="1678791089"/>
+        <p14:creationId xmlns:p14="http://schemas.microsoft.com/office/powerpoint/2010/main" val="1295911707"/>
       </p:ext>
     </p:extLst>
   </p:cSld>
@@ -8075,7 +8075,7 @@
           <p:cNvPr id="9" name="">
             <a:extLst xmlns:a="http://schemas.openxmlformats.org/drawingml/2006/main">
               <a:ext uri="{FF2B5EF4-FFF2-40B4-BE49-F238E27FC236}">
-                <a16:creationId xmlns:a16="http://schemas.microsoft.com/office/drawing/2014/main" id="{6346AFDD-60E8-47AF-A393-70A73F38AF18}"/>
+                <a16:creationId xmlns:a16="http://schemas.microsoft.com/office/drawing/2014/main" id="{4E21C098-6563-4A9D-8E31-F21E72669BF3}"/>
               </a:ext>
             </a:extLst>
           </p:cNvPr>
@@ -8232,7 +8232,7 @@
           <p:cNvPr id="2" name="">
             <a:extLst xmlns:a="http://schemas.openxmlformats.org/drawingml/2006/main">
               <a:ext uri="{FF2B5EF4-FFF2-40B4-BE49-F238E27FC236}">
-                <a16:creationId xmlns:a16="http://schemas.microsoft.com/office/drawing/2014/main" id="{3A5CD086-9443-436B-98B5-6495EBA14716}"/>
+                <a16:creationId xmlns:a16="http://schemas.microsoft.com/office/drawing/2014/main" id="{4A0089AE-1BC5-4A55-BC1A-707C0699F409}"/>
               </a:ext>
             </a:extLst>
           </p:cNvPr>
@@ -8263,7 +8263,7 @@
           <p:cNvPr id="3" name="">
             <a:extLst xmlns:a="http://schemas.openxmlformats.org/drawingml/2006/main">
               <a:ext uri="{FF2B5EF4-FFF2-40B4-BE49-F238E27FC236}">
-                <a16:creationId xmlns:a16="http://schemas.microsoft.com/office/drawing/2014/main" id="{723F97CB-59EB-4EF8-996D-D2036CD2ABD7}"/>
+                <a16:creationId xmlns:a16="http://schemas.microsoft.com/office/drawing/2014/main" id="{44326CD8-53FD-47A2-A6FD-5F96C2625D26}"/>
               </a:ext>
             </a:extLst>
           </p:cNvPr>
@@ -8420,7 +8420,7 @@
           <p:cNvPr id="4" name="">
             <a:extLst xmlns:a="http://schemas.openxmlformats.org/drawingml/2006/main">
               <a:ext uri="{FF2B5EF4-FFF2-40B4-BE49-F238E27FC236}">
-                <a16:creationId xmlns:a16="http://schemas.microsoft.com/office/drawing/2014/main" id="{4227C21B-6795-4FC2-863F-F0EE33B18F7E}"/>
+                <a16:creationId xmlns:a16="http://schemas.microsoft.com/office/drawing/2014/main" id="{72008909-7565-4948-A64C-E80DBCDB09A0}"/>
               </a:ext>
             </a:extLst>
           </p:cNvPr>
@@ -8577,7 +8577,7 @@
           <p:cNvPr id="5" name="">
             <a:extLst xmlns:a="http://schemas.openxmlformats.org/drawingml/2006/main">
               <a:ext uri="{FF2B5EF4-FFF2-40B4-BE49-F238E27FC236}">
-                <a16:creationId xmlns:a16="http://schemas.microsoft.com/office/drawing/2014/main" id="{167FA535-94C4-47BE-B5FA-296D5F8CF334}"/>
+                <a16:creationId xmlns:a16="http://schemas.microsoft.com/office/drawing/2014/main" id="{52EBA764-82A9-4522-9D3D-447D9D2B3238}"/>
               </a:ext>
             </a:extLst>
           </p:cNvPr>
@@ -8734,7 +8734,7 @@
           <p:cNvPr id="6" name="">
             <a:extLst xmlns:a="http://schemas.openxmlformats.org/drawingml/2006/main">
               <a:ext uri="{FF2B5EF4-FFF2-40B4-BE49-F238E27FC236}">
-                <a16:creationId xmlns:a16="http://schemas.microsoft.com/office/drawing/2014/main" id="{5F96A421-E71B-4A71-97ED-4235D21127AF}"/>
+                <a16:creationId xmlns:a16="http://schemas.microsoft.com/office/drawing/2014/main" id="{A7CD81B1-6ABD-46A3-897D-52D1F2E5AA3A}"/>
               </a:ext>
             </a:extLst>
           </p:cNvPr>
@@ -8914,7 +8914,7 @@
           <p:cNvPr id="7" name="">
             <a:extLst xmlns:a="http://schemas.openxmlformats.org/drawingml/2006/main">
               <a:ext uri="{FF2B5EF4-FFF2-40B4-BE49-F238E27FC236}">
-                <a16:creationId xmlns:a16="http://schemas.microsoft.com/office/drawing/2014/main" id="{7818B792-3B92-4F89-A2DC-342B40DFB014}"/>
+                <a16:creationId xmlns:a16="http://schemas.microsoft.com/office/drawing/2014/main" id="{8692200B-29D4-4818-8134-2124982C01BE}"/>
               </a:ext>
             </a:extLst>
           </p:cNvPr>
@@ -9071,7 +9071,7 @@
           <p:cNvPr id="8" name="">
             <a:extLst xmlns:a="http://schemas.openxmlformats.org/drawingml/2006/main">
               <a:ext uri="{FF2B5EF4-FFF2-40B4-BE49-F238E27FC236}">
-                <a16:creationId xmlns:a16="http://schemas.microsoft.com/office/drawing/2014/main" id="{7A5818A4-8C60-4781-AF35-5144E9751E08}"/>
+                <a16:creationId xmlns:a16="http://schemas.microsoft.com/office/drawing/2014/main" id="{31809951-9977-4AFA-95FF-D5DF5ABB0666}"/>
               </a:ext>
             </a:extLst>
           </p:cNvPr>
@@ -9226,7 +9226,7 @@
     </p:spTree>
     <p:extLst>
       <p:ext uri="{BB962C8B-B14F-4D97-AF65-F5344CB8AC3E}">
-        <p14:creationId xmlns:p14="http://schemas.microsoft.com/office/powerpoint/2010/main" val="328955681"/>
+        <p14:creationId xmlns:p14="http://schemas.microsoft.com/office/powerpoint/2010/main" val="337102522"/>
       </p:ext>
     </p:extLst>
   </p:cSld>
@@ -9257,7 +9257,7 @@
           <p:cNvPr id="8" name="">
             <a:extLst xmlns:a="http://schemas.openxmlformats.org/drawingml/2006/main">
               <a:ext uri="{FF2B5EF4-FFF2-40B4-BE49-F238E27FC236}">
-                <a16:creationId xmlns:a16="http://schemas.microsoft.com/office/drawing/2014/main" id="{DDD9EA37-E81A-40A2-9088-A5B39E98FC1D}"/>
+                <a16:creationId xmlns:a16="http://schemas.microsoft.com/office/drawing/2014/main" id="{A46C5C64-1654-449D-B34B-2249BE7F9D8B}"/>
               </a:ext>
             </a:extLst>
           </p:cNvPr>
@@ -9414,7 +9414,7 @@
           <p:cNvPr id="2" name="">
             <a:extLst xmlns:a="http://schemas.openxmlformats.org/drawingml/2006/main">
               <a:ext uri="{FF2B5EF4-FFF2-40B4-BE49-F238E27FC236}">
-                <a16:creationId xmlns:a16="http://schemas.microsoft.com/office/drawing/2014/main" id="{2BB5695B-E5F3-4BF1-9B09-2146C3D1CFA4}"/>
+                <a16:creationId xmlns:a16="http://schemas.microsoft.com/office/drawing/2014/main" id="{2AF7B47E-C00F-466F-A824-528CBF2D83FD}"/>
               </a:ext>
             </a:extLst>
           </p:cNvPr>
@@ -9445,7 +9445,7 @@
           <p:cNvPr id="3" name="">
             <a:extLst xmlns:a="http://schemas.openxmlformats.org/drawingml/2006/main">
               <a:ext uri="{FF2B5EF4-FFF2-40B4-BE49-F238E27FC236}">
-                <a16:creationId xmlns:a16="http://schemas.microsoft.com/office/drawing/2014/main" id="{1474899E-3610-47FC-B71D-5A57209EACD4}"/>
+                <a16:creationId xmlns:a16="http://schemas.microsoft.com/office/drawing/2014/main" id="{DE477B05-A774-4575-86F3-E1E9DA212801}"/>
               </a:ext>
             </a:extLst>
           </p:cNvPr>
@@ -9602,7 +9602,7 @@
           <p:cNvPr id="4" name="">
             <a:extLst xmlns:a="http://schemas.openxmlformats.org/drawingml/2006/main">
               <a:ext uri="{FF2B5EF4-FFF2-40B4-BE49-F238E27FC236}">
-                <a16:creationId xmlns:a16="http://schemas.microsoft.com/office/drawing/2014/main" id="{6082245F-8602-4575-AFD3-CA5F6CD82F6E}"/>
+                <a16:creationId xmlns:a16="http://schemas.microsoft.com/office/drawing/2014/main" id="{0F6543D8-7722-42DA-BA58-2F0AEDF0C859}"/>
               </a:ext>
             </a:extLst>
           </p:cNvPr>
@@ -9759,7 +9759,7 @@
           <p:cNvPr id="5" name="">
             <a:extLst xmlns:a="http://schemas.openxmlformats.org/drawingml/2006/main">
               <a:ext uri="{FF2B5EF4-FFF2-40B4-BE49-F238E27FC236}">
-                <a16:creationId xmlns:a16="http://schemas.microsoft.com/office/drawing/2014/main" id="{E7688C8C-C8F4-449D-BA3B-B2DC8C40B1A4}"/>
+                <a16:creationId xmlns:a16="http://schemas.microsoft.com/office/drawing/2014/main" id="{D3A9EFD5-BEFA-47B2-B9FA-5ACDB2632943}"/>
               </a:ext>
             </a:extLst>
           </p:cNvPr>
@@ -9916,7 +9916,7 @@
           <p:cNvPr id="6" name="">
             <a:extLst xmlns:a="http://schemas.openxmlformats.org/drawingml/2006/main">
               <a:ext uri="{FF2B5EF4-FFF2-40B4-BE49-F238E27FC236}">
-                <a16:creationId xmlns:a16="http://schemas.microsoft.com/office/drawing/2014/main" id="{AF243309-D46B-429B-9EAB-204EFA191EB4}"/>
+                <a16:creationId xmlns:a16="http://schemas.microsoft.com/office/drawing/2014/main" id="{4F179BC8-DEC1-473D-A142-75919D701E61}"/>
               </a:ext>
             </a:extLst>
           </p:cNvPr>
@@ -10073,7 +10073,7 @@
           <p:cNvPr id="7" name="">
             <a:extLst xmlns:a="http://schemas.openxmlformats.org/drawingml/2006/main">
               <a:ext uri="{FF2B5EF4-FFF2-40B4-BE49-F238E27FC236}">
-                <a16:creationId xmlns:a16="http://schemas.microsoft.com/office/drawing/2014/main" id="{92D98085-3F51-44FC-9BD3-4E3693AD0835}"/>
+                <a16:creationId xmlns:a16="http://schemas.microsoft.com/office/drawing/2014/main" id="{14F5D0EF-F125-44A2-A04E-8FA5D7279D47}"/>
               </a:ext>
             </a:extLst>
           </p:cNvPr>
@@ -10228,7 +10228,7 @@
     </p:spTree>
     <p:extLst>
       <p:ext uri="{BB962C8B-B14F-4D97-AF65-F5344CB8AC3E}">
-        <p14:creationId xmlns:p14="http://schemas.microsoft.com/office/powerpoint/2010/main" val="1729564775"/>
+        <p14:creationId xmlns:p14="http://schemas.microsoft.com/office/powerpoint/2010/main" val="1406288474"/>
       </p:ext>
     </p:extLst>
   </p:cSld>
@@ -10259,7 +10259,7 @@
           <p:cNvPr id="6" name="">
             <a:extLst xmlns:a="http://schemas.openxmlformats.org/drawingml/2006/main">
               <a:ext uri="{FF2B5EF4-FFF2-40B4-BE49-F238E27FC236}">
-                <a16:creationId xmlns:a16="http://schemas.microsoft.com/office/drawing/2014/main" id="{6A4933E0-5694-484E-B55D-39940EF81090}"/>
+                <a16:creationId xmlns:a16="http://schemas.microsoft.com/office/drawing/2014/main" id="{56262A36-F04B-4759-BC54-4E213496B638}"/>
               </a:ext>
             </a:extLst>
           </p:cNvPr>
@@ -10416,7 +10416,7 @@
           <p:cNvPr id="2" name="">
             <a:extLst xmlns:a="http://schemas.openxmlformats.org/drawingml/2006/main">
               <a:ext uri="{FF2B5EF4-FFF2-40B4-BE49-F238E27FC236}">
-                <a16:creationId xmlns:a16="http://schemas.microsoft.com/office/drawing/2014/main" id="{790CAFF7-7B3E-420B-952F-958FC5FE4A92}"/>
+                <a16:creationId xmlns:a16="http://schemas.microsoft.com/office/drawing/2014/main" id="{341CD0E7-460D-4DBE-AB66-0553CE48BC3A}"/>
               </a:ext>
             </a:extLst>
           </p:cNvPr>
@@ -10447,7 +10447,7 @@
           <p:cNvPr id="3" name="">
             <a:extLst xmlns:a="http://schemas.openxmlformats.org/drawingml/2006/main">
               <a:ext uri="{FF2B5EF4-FFF2-40B4-BE49-F238E27FC236}">
-                <a16:creationId xmlns:a16="http://schemas.microsoft.com/office/drawing/2014/main" id="{526BE8A6-305A-4FA7-A496-8531D73942CC}"/>
+                <a16:creationId xmlns:a16="http://schemas.microsoft.com/office/drawing/2014/main" id="{59204D70-D432-466A-A5AE-2A33534DA263}"/>
               </a:ext>
             </a:extLst>
           </p:cNvPr>
@@ -10604,7 +10604,7 @@
           <p:cNvPr id="4" name="">
             <a:extLst xmlns:a="http://schemas.openxmlformats.org/drawingml/2006/main">
               <a:ext uri="{FF2B5EF4-FFF2-40B4-BE49-F238E27FC236}">
-                <a16:creationId xmlns:a16="http://schemas.microsoft.com/office/drawing/2014/main" id="{5A5B2239-A828-4EC3-B7E2-42083CC2B498}"/>
+                <a16:creationId xmlns:a16="http://schemas.microsoft.com/office/drawing/2014/main" id="{A4016BD7-73D8-45F3-836B-06D3F4E653F0}"/>
               </a:ext>
             </a:extLst>
           </p:cNvPr>
@@ -11044,7 +11044,7 @@
           <p:cNvPr id="5" name="">
             <a:extLst xmlns:a="http://schemas.openxmlformats.org/drawingml/2006/main">
               <a:ext uri="{FF2B5EF4-FFF2-40B4-BE49-F238E27FC236}">
-                <a16:creationId xmlns:a16="http://schemas.microsoft.com/office/drawing/2014/main" id="{AD07E5A2-3457-402A-8972-D5125256B539}"/>
+                <a16:creationId xmlns:a16="http://schemas.microsoft.com/office/drawing/2014/main" id="{EDE93DE0-4434-4B38-9FC9-957D094BAD9C}"/>
               </a:ext>
             </a:extLst>
           </p:cNvPr>
@@ -11199,7 +11199,7 @@
     </p:spTree>
     <p:extLst>
       <p:ext uri="{BB962C8B-B14F-4D97-AF65-F5344CB8AC3E}">
-        <p14:creationId xmlns:p14="http://schemas.microsoft.com/office/powerpoint/2010/main" val="548703656"/>
+        <p14:creationId xmlns:p14="http://schemas.microsoft.com/office/powerpoint/2010/main" val="349689253"/>
       </p:ext>
     </p:extLst>
   </p:cSld>
@@ -11230,7 +11230,7 @@
           <p:cNvPr id="18" name="">
             <a:extLst xmlns:a="http://schemas.openxmlformats.org/drawingml/2006/main">
               <a:ext uri="{FF2B5EF4-FFF2-40B4-BE49-F238E27FC236}">
-                <a16:creationId xmlns:a16="http://schemas.microsoft.com/office/drawing/2014/main" id="{7975F211-A904-4269-B773-F6155C646DDB}"/>
+                <a16:creationId xmlns:a16="http://schemas.microsoft.com/office/drawing/2014/main" id="{29781FB8-4550-4CEE-A486-C1267DCF4977}"/>
               </a:ext>
             </a:extLst>
           </p:cNvPr>
@@ -11387,7 +11387,7 @@
           <p:cNvPr id="2" name="">
             <a:extLst xmlns:a="http://schemas.openxmlformats.org/drawingml/2006/main">
               <a:ext uri="{FF2B5EF4-FFF2-40B4-BE49-F238E27FC236}">
-                <a16:creationId xmlns:a16="http://schemas.microsoft.com/office/drawing/2014/main" id="{77B67723-FC1B-4A2C-B266-0A04306C93C6}"/>
+                <a16:creationId xmlns:a16="http://schemas.microsoft.com/office/drawing/2014/main" id="{7B7BB1E5-EE5C-4C19-A007-6D909F47E0DC}"/>
               </a:ext>
             </a:extLst>
           </p:cNvPr>
@@ -11418,7 +11418,7 @@
           <p:cNvPr id="3" name="">
             <a:extLst xmlns:a="http://schemas.openxmlformats.org/drawingml/2006/main">
               <a:ext uri="{FF2B5EF4-FFF2-40B4-BE49-F238E27FC236}">
-                <a16:creationId xmlns:a16="http://schemas.microsoft.com/office/drawing/2014/main" id="{70E09AD9-825F-4C06-B83B-211E2FD0EB92}"/>
+                <a16:creationId xmlns:a16="http://schemas.microsoft.com/office/drawing/2014/main" id="{E57B832E-58C6-41AE-9F93-84ADFAEBBC31}"/>
               </a:ext>
             </a:extLst>
           </p:cNvPr>
@@ -11575,7 +11575,7 @@
           <p:cNvPr id="4" name="">
             <a:extLst xmlns:a="http://schemas.openxmlformats.org/drawingml/2006/main">
               <a:ext uri="{FF2B5EF4-FFF2-40B4-BE49-F238E27FC236}">
-                <a16:creationId xmlns:a16="http://schemas.microsoft.com/office/drawing/2014/main" id="{309E02DC-A27A-4CDA-95CF-02E00DF005D8}"/>
+                <a16:creationId xmlns:a16="http://schemas.microsoft.com/office/drawing/2014/main" id="{B7D55048-56D7-442E-8D6B-521562ECA169}"/>
               </a:ext>
             </a:extLst>
           </p:cNvPr>
@@ -11606,7 +11606,7 @@
           <p:cNvPr id="5" name="">
             <a:extLst xmlns:a="http://schemas.openxmlformats.org/drawingml/2006/main">
               <a:ext uri="{FF2B5EF4-FFF2-40B4-BE49-F238E27FC236}">
-                <a16:creationId xmlns:a16="http://schemas.microsoft.com/office/drawing/2014/main" id="{F5B468B0-2A9D-4EE9-B379-8EF36614FD05}"/>
+                <a16:creationId xmlns:a16="http://schemas.microsoft.com/office/drawing/2014/main" id="{777F1BB7-E589-4372-A8F9-88806D47AFE2}"/>
               </a:ext>
             </a:extLst>
           </p:cNvPr>
@@ -11763,7 +11763,7 @@
           <p:cNvPr id="6" name="">
             <a:extLst xmlns:a="http://schemas.openxmlformats.org/drawingml/2006/main">
               <a:ext uri="{FF2B5EF4-FFF2-40B4-BE49-F238E27FC236}">
-                <a16:creationId xmlns:a16="http://schemas.microsoft.com/office/drawing/2014/main" id="{FCA1B7A6-33B7-4076-9F2F-0F6597AB92D1}"/>
+                <a16:creationId xmlns:a16="http://schemas.microsoft.com/office/drawing/2014/main" id="{D6926695-5376-4EA5-8EB7-FC073C1885C9}"/>
               </a:ext>
             </a:extLst>
           </p:cNvPr>
@@ -11920,7 +11920,7 @@
           <p:cNvPr id="7" name="">
             <a:extLst xmlns:a="http://schemas.openxmlformats.org/drawingml/2006/main">
               <a:ext uri="{FF2B5EF4-FFF2-40B4-BE49-F238E27FC236}">
-                <a16:creationId xmlns:a16="http://schemas.microsoft.com/office/drawing/2014/main" id="{3BFE55A0-10C8-44A0-B1AD-CC4F57AC0427}"/>
+                <a16:creationId xmlns:a16="http://schemas.microsoft.com/office/drawing/2014/main" id="{367FAB30-A08E-48B8-8351-FD6770370E3B}"/>
               </a:ext>
             </a:extLst>
           </p:cNvPr>
@@ -11951,7 +11951,7 @@
           <p:cNvPr id="8" name="">
             <a:extLst xmlns:a="http://schemas.openxmlformats.org/drawingml/2006/main">
               <a:ext uri="{FF2B5EF4-FFF2-40B4-BE49-F238E27FC236}">
-                <a16:creationId xmlns:a16="http://schemas.microsoft.com/office/drawing/2014/main" id="{7ACD0F7E-4DD0-4A4B-84F8-0CAE02AC7C03}"/>
+                <a16:creationId xmlns:a16="http://schemas.microsoft.com/office/drawing/2014/main" id="{520B8983-1865-4D3C-8C87-53189D967664}"/>
               </a:ext>
             </a:extLst>
           </p:cNvPr>
@@ -12108,7 +12108,7 @@
           <p:cNvPr id="9" name="">
             <a:extLst xmlns:a="http://schemas.openxmlformats.org/drawingml/2006/main">
               <a:ext uri="{FF2B5EF4-FFF2-40B4-BE49-F238E27FC236}">
-                <a16:creationId xmlns:a16="http://schemas.microsoft.com/office/drawing/2014/main" id="{C8733924-41EB-45F6-A21B-BA5BEFB949B8}"/>
+                <a16:creationId xmlns:a16="http://schemas.microsoft.com/office/drawing/2014/main" id="{C30224E7-8492-443E-95C7-B9A440B13327}"/>
               </a:ext>
             </a:extLst>
           </p:cNvPr>
@@ -12265,7 +12265,7 @@
           <p:cNvPr id="10" name="">
             <a:extLst xmlns:a="http://schemas.openxmlformats.org/drawingml/2006/main">
               <a:ext uri="{FF2B5EF4-FFF2-40B4-BE49-F238E27FC236}">
-                <a16:creationId xmlns:a16="http://schemas.microsoft.com/office/drawing/2014/main" id="{F979B2CD-F437-4A88-A938-8BC01FCE8BDD}"/>
+                <a16:creationId xmlns:a16="http://schemas.microsoft.com/office/drawing/2014/main" id="{9D776742-8F72-4D39-8B3F-14671A60D0CE}"/>
               </a:ext>
             </a:extLst>
           </p:cNvPr>
@@ -12296,7 +12296,7 @@
           <p:cNvPr id="11" name="">
             <a:extLst xmlns:a="http://schemas.openxmlformats.org/drawingml/2006/main">
               <a:ext uri="{FF2B5EF4-FFF2-40B4-BE49-F238E27FC236}">
-                <a16:creationId xmlns:a16="http://schemas.microsoft.com/office/drawing/2014/main" id="{7E9B72FF-81EC-4A18-9A8E-694F82973611}"/>
+                <a16:creationId xmlns:a16="http://schemas.microsoft.com/office/drawing/2014/main" id="{0F5A6DBE-F13D-43E2-B752-860209A693EC}"/>
               </a:ext>
             </a:extLst>
           </p:cNvPr>
@@ -12453,7 +12453,7 @@
           <p:cNvPr id="12" name="">
             <a:extLst xmlns:a="http://schemas.openxmlformats.org/drawingml/2006/main">
               <a:ext uri="{FF2B5EF4-FFF2-40B4-BE49-F238E27FC236}">
-                <a16:creationId xmlns:a16="http://schemas.microsoft.com/office/drawing/2014/main" id="{4A460272-2C58-4E0A-9C18-7ACEA963EE0E}"/>
+                <a16:creationId xmlns:a16="http://schemas.microsoft.com/office/drawing/2014/main" id="{A50E0375-611C-42B7-B74C-3F6349ED2749}"/>
               </a:ext>
             </a:extLst>
           </p:cNvPr>
@@ -12610,7 +12610,7 @@
           <p:cNvPr id="13" name="">
             <a:extLst xmlns:a="http://schemas.openxmlformats.org/drawingml/2006/main">
               <a:ext uri="{FF2B5EF4-FFF2-40B4-BE49-F238E27FC236}">
-                <a16:creationId xmlns:a16="http://schemas.microsoft.com/office/drawing/2014/main" id="{426AF9BB-8FE4-42ED-89D4-15631994A971}"/>
+                <a16:creationId xmlns:a16="http://schemas.microsoft.com/office/drawing/2014/main" id="{E3DAA20B-6E6F-4627-8394-237B9E91A507}"/>
               </a:ext>
             </a:extLst>
           </p:cNvPr>
@@ -12641,7 +12641,7 @@
           <p:cNvPr id="14" name="">
             <a:extLst xmlns:a="http://schemas.openxmlformats.org/drawingml/2006/main">
               <a:ext uri="{FF2B5EF4-FFF2-40B4-BE49-F238E27FC236}">
-                <a16:creationId xmlns:a16="http://schemas.microsoft.com/office/drawing/2014/main" id="{82D4DBEA-1C17-44EC-8205-B0314FEE52B5}"/>
+                <a16:creationId xmlns:a16="http://schemas.microsoft.com/office/drawing/2014/main" id="{ED1AF782-245C-4CD5-9216-CD7186D7E163}"/>
               </a:ext>
             </a:extLst>
           </p:cNvPr>
@@ -12821,7 +12821,7 @@
           <p:cNvPr id="15" name="">
             <a:extLst xmlns:a="http://schemas.openxmlformats.org/drawingml/2006/main">
               <a:ext uri="{FF2B5EF4-FFF2-40B4-BE49-F238E27FC236}">
-                <a16:creationId xmlns:a16="http://schemas.microsoft.com/office/drawing/2014/main" id="{0321B33A-9926-47D7-AACA-6B9474DE628B}"/>
+                <a16:creationId xmlns:a16="http://schemas.microsoft.com/office/drawing/2014/main" id="{B62A88B4-77D5-402D-BF87-26B137E7648B}"/>
               </a:ext>
             </a:extLst>
           </p:cNvPr>
@@ -12978,7 +12978,7 @@
           <p:cNvPr id="16" name="">
             <a:extLst xmlns:a="http://schemas.openxmlformats.org/drawingml/2006/main">
               <a:ext uri="{FF2B5EF4-FFF2-40B4-BE49-F238E27FC236}">
-                <a16:creationId xmlns:a16="http://schemas.microsoft.com/office/drawing/2014/main" id="{D48A6C3B-052F-41B0-B917-799F4D2D09CE}"/>
+                <a16:creationId xmlns:a16="http://schemas.microsoft.com/office/drawing/2014/main" id="{08359E17-1E7B-4CF5-980C-11CFC870C6FE}"/>
               </a:ext>
             </a:extLst>
           </p:cNvPr>
@@ -13181,7 +13181,7 @@
           <p:cNvPr id="17" name="">
             <a:extLst xmlns:a="http://schemas.openxmlformats.org/drawingml/2006/main">
               <a:ext uri="{FF2B5EF4-FFF2-40B4-BE49-F238E27FC236}">
-                <a16:creationId xmlns:a16="http://schemas.microsoft.com/office/drawing/2014/main" id="{74CB8672-4025-4165-B5CF-0FDF6AB414A5}"/>
+                <a16:creationId xmlns:a16="http://schemas.microsoft.com/office/drawing/2014/main" id="{D0320FDA-773B-487C-ABF0-06F8C59A9769}"/>
               </a:ext>
             </a:extLst>
           </p:cNvPr>
@@ -13336,7 +13336,7 @@
     </p:spTree>
     <p:extLst>
       <p:ext uri="{BB962C8B-B14F-4D97-AF65-F5344CB8AC3E}">
-        <p14:creationId xmlns:p14="http://schemas.microsoft.com/office/powerpoint/2010/main" val="429463484"/>
+        <p14:creationId xmlns:p14="http://schemas.microsoft.com/office/powerpoint/2010/main" val="1023783923"/>
       </p:ext>
     </p:extLst>
   </p:cSld>
@@ -13367,7 +13367,7 @@
           <p:cNvPr id="7" name="">
             <a:extLst xmlns:a="http://schemas.openxmlformats.org/drawingml/2006/main">
               <a:ext uri="{FF2B5EF4-FFF2-40B4-BE49-F238E27FC236}">
-                <a16:creationId xmlns:a16="http://schemas.microsoft.com/office/drawing/2014/main" id="{91ECB5EA-307F-4060-BEE0-6BDDDEDD63A5}"/>
+                <a16:creationId xmlns:a16="http://schemas.microsoft.com/office/drawing/2014/main" id="{2156F0F0-EEC8-457C-9E33-03F86CB46BC0}"/>
               </a:ext>
             </a:extLst>
           </p:cNvPr>
@@ -13524,7 +13524,7 @@
           <p:cNvPr id="2" name="">
             <a:extLst xmlns:a="http://schemas.openxmlformats.org/drawingml/2006/main">
               <a:ext uri="{FF2B5EF4-FFF2-40B4-BE49-F238E27FC236}">
-                <a16:creationId xmlns:a16="http://schemas.microsoft.com/office/drawing/2014/main" id="{7747CF3E-739C-4692-B9EA-722362E5C1C2}"/>
+                <a16:creationId xmlns:a16="http://schemas.microsoft.com/office/drawing/2014/main" id="{59380CB2-BF6B-44B0-9354-7EAF75123BBF}"/>
               </a:ext>
             </a:extLst>
           </p:cNvPr>
@@ -13555,7 +13555,7 @@
           <p:cNvPr id="3" name="">
             <a:extLst xmlns:a="http://schemas.openxmlformats.org/drawingml/2006/main">
               <a:ext uri="{FF2B5EF4-FFF2-40B4-BE49-F238E27FC236}">
-                <a16:creationId xmlns:a16="http://schemas.microsoft.com/office/drawing/2014/main" id="{B251C3CE-5998-4D68-991A-7E52B8B76D2C}"/>
+                <a16:creationId xmlns:a16="http://schemas.microsoft.com/office/drawing/2014/main" id="{DD697BF3-34D6-4AD6-A6FD-1C49D89A3077}"/>
               </a:ext>
             </a:extLst>
           </p:cNvPr>
@@ -13712,7 +13712,7 @@
           <p:cNvPr id="4" name="">
             <a:extLst xmlns:a="http://schemas.openxmlformats.org/drawingml/2006/main">
               <a:ext uri="{FF2B5EF4-FFF2-40B4-BE49-F238E27FC236}">
-                <a16:creationId xmlns:a16="http://schemas.microsoft.com/office/drawing/2014/main" id="{37DF9616-D7DA-4E3C-BC24-45110182D182}"/>
+                <a16:creationId xmlns:a16="http://schemas.microsoft.com/office/drawing/2014/main" id="{4009934C-E482-4437-8D29-B4944D2D600E}"/>
               </a:ext>
             </a:extLst>
           </p:cNvPr>
@@ -13722,7 +13722,7 @@
           <p:nvPr/>
         </p:nvPicPr>
         <p:blipFill>
-          <a:blip xmlns:r="http://schemas.openxmlformats.org/officeDocument/2006/relationships" xmlns:a="http://schemas.openxmlformats.org/drawingml/2006/main" r:embed="R88461021c8834bea"/>
+          <a:blip xmlns:r="http://schemas.openxmlformats.org/officeDocument/2006/relationships" xmlns:a="http://schemas.openxmlformats.org/drawingml/2006/main" r:embed="R40e8f6d20849468d"/>
           <a:stretch xmlns:a="http://schemas.openxmlformats.org/drawingml/2006/main"/>
         </p:blipFill>
         <p:spPr>
@@ -13740,7 +13740,7 @@
           <p:cNvPr id="5" name="">
             <a:extLst xmlns:a="http://schemas.openxmlformats.org/drawingml/2006/main">
               <a:ext uri="{FF2B5EF4-FFF2-40B4-BE49-F238E27FC236}">
-                <a16:creationId xmlns:a16="http://schemas.microsoft.com/office/drawing/2014/main" id="{7F25A289-FF86-4FC7-A8CE-F6B9A5413F02}"/>
+                <a16:creationId xmlns:a16="http://schemas.microsoft.com/office/drawing/2014/main" id="{F60848BC-C56C-48BD-95E7-88AC6B2E81F6}"/>
               </a:ext>
             </a:extLst>
           </p:cNvPr>
@@ -13943,7 +13943,7 @@
           <p:cNvPr id="6" name="">
             <a:extLst xmlns:a="http://schemas.openxmlformats.org/drawingml/2006/main">
               <a:ext uri="{FF2B5EF4-FFF2-40B4-BE49-F238E27FC236}">
-                <a16:creationId xmlns:a16="http://schemas.microsoft.com/office/drawing/2014/main" id="{4784226D-6E45-4DBF-BD66-DF9AFC1EF7E5}"/>
+                <a16:creationId xmlns:a16="http://schemas.microsoft.com/office/drawing/2014/main" id="{E1C92FBD-E208-4EFD-9A12-FC4E61C91EC8}"/>
               </a:ext>
             </a:extLst>
           </p:cNvPr>
@@ -14144,7 +14144,7 @@
     </p:spTree>
     <p:extLst>
       <p:ext uri="{BB962C8B-B14F-4D97-AF65-F5344CB8AC3E}">
-        <p14:creationId xmlns:p14="http://schemas.microsoft.com/office/powerpoint/2010/main" val="424459328"/>
+        <p14:creationId xmlns:p14="http://schemas.microsoft.com/office/powerpoint/2010/main" val="1488444642"/>
       </p:ext>
     </p:extLst>
   </p:cSld>
@@ -14175,7 +14175,7 @@
           <p:cNvPr id="6" name="">
             <a:extLst xmlns:a="http://schemas.openxmlformats.org/drawingml/2006/main">
               <a:ext uri="{FF2B5EF4-FFF2-40B4-BE49-F238E27FC236}">
-                <a16:creationId xmlns:a16="http://schemas.microsoft.com/office/drawing/2014/main" id="{25FB50E1-58A3-4F73-9A5B-998530C4B686}"/>
+                <a16:creationId xmlns:a16="http://schemas.microsoft.com/office/drawing/2014/main" id="{CC076953-7267-43FA-9605-8EADED96B97D}"/>
               </a:ext>
             </a:extLst>
           </p:cNvPr>
@@ -14332,7 +14332,7 @@
           <p:cNvPr id="2" name="">
             <a:extLst xmlns:a="http://schemas.openxmlformats.org/drawingml/2006/main">
               <a:ext uri="{FF2B5EF4-FFF2-40B4-BE49-F238E27FC236}">
-                <a16:creationId xmlns:a16="http://schemas.microsoft.com/office/drawing/2014/main" id="{E4A30AEC-5156-4382-806C-DAAA043336C3}"/>
+                <a16:creationId xmlns:a16="http://schemas.microsoft.com/office/drawing/2014/main" id="{A6CAC7A5-A2AA-487D-95B1-F7D2AB69AD52}"/>
               </a:ext>
             </a:extLst>
           </p:cNvPr>
@@ -14363,7 +14363,7 @@
           <p:cNvPr id="3" name="">
             <a:extLst xmlns:a="http://schemas.openxmlformats.org/drawingml/2006/main">
               <a:ext uri="{FF2B5EF4-FFF2-40B4-BE49-F238E27FC236}">
-                <a16:creationId xmlns:a16="http://schemas.microsoft.com/office/drawing/2014/main" id="{10658A14-40F0-4414-A2CC-20B821485505}"/>
+                <a16:creationId xmlns:a16="http://schemas.microsoft.com/office/drawing/2014/main" id="{F37D7CEC-62D0-4C81-BB3E-4343306B593F}"/>
               </a:ext>
             </a:extLst>
           </p:cNvPr>
@@ -14520,7 +14520,7 @@
           <p:cNvPr id="4" name="">
             <a:extLst xmlns:a="http://schemas.openxmlformats.org/drawingml/2006/main">
               <a:ext uri="{FF2B5EF4-FFF2-40B4-BE49-F238E27FC236}">
-                <a16:creationId xmlns:a16="http://schemas.microsoft.com/office/drawing/2014/main" id="{4D4FCEE8-D228-40DB-9805-5A4199D5E267}"/>
+                <a16:creationId xmlns:a16="http://schemas.microsoft.com/office/drawing/2014/main" id="{1DE1C5CE-E23B-4AD4-9BC1-38BE6000697C}"/>
               </a:ext>
             </a:extLst>
           </p:cNvPr>
@@ -14530,13 +14530,13 @@
           <p:nvPr/>
         </p:nvPicPr>
         <p:blipFill>
-          <a:blip xmlns:r="http://schemas.openxmlformats.org/officeDocument/2006/relationships" xmlns:a="http://schemas.openxmlformats.org/drawingml/2006/main" r:embed="R8aafba8252304c2e"/>
+          <a:blip xmlns:r="http://schemas.openxmlformats.org/officeDocument/2006/relationships" xmlns:a="http://schemas.openxmlformats.org/drawingml/2006/main" r:embed="Re2ffcc4daff145f9"/>
           <a:stretch xmlns:a="http://schemas.openxmlformats.org/drawingml/2006/main"/>
         </p:blipFill>
         <p:spPr>
           <a:xfrm xmlns:a="http://schemas.openxmlformats.org/drawingml/2006/main">
-            <a:off x="747273" y="2095500"/>
-            <a:ext cx="10697455" cy="3333750"/>
+            <a:off x="834847" y="1905000"/>
+            <a:ext cx="10522307" cy="3810000"/>
           </a:xfrm>
           <a:prstGeom xmlns:a="http://schemas.openxmlformats.org/drawingml/2006/main" prst="rect">
             <a:avLst/>
@@ -14548,7 +14548,7 @@
           <p:cNvPr id="5" name="">
             <a:extLst xmlns:a="http://schemas.openxmlformats.org/drawingml/2006/main">
               <a:ext uri="{FF2B5EF4-FFF2-40B4-BE49-F238E27FC236}">
-                <a16:creationId xmlns:a16="http://schemas.microsoft.com/office/drawing/2014/main" id="{09CEF9E4-6C69-4E65-A015-9CA8E8FAB68E}"/>
+                <a16:creationId xmlns:a16="http://schemas.microsoft.com/office/drawing/2014/main" id="{CE39BD94-C2D3-43A3-836C-DDCFD12E8495}"/>
               </a:ext>
             </a:extLst>
           </p:cNvPr>
@@ -14703,7 +14703,7 @@
     </p:spTree>
     <p:extLst>
       <p:ext uri="{BB962C8B-B14F-4D97-AF65-F5344CB8AC3E}">
-        <p14:creationId xmlns:p14="http://schemas.microsoft.com/office/powerpoint/2010/main" val="1036209017"/>
+        <p14:creationId xmlns:p14="http://schemas.microsoft.com/office/powerpoint/2010/main" val="308034031"/>
       </p:ext>
     </p:extLst>
   </p:cSld>
@@ -14734,7 +14734,7 @@
           <p:cNvPr id="6" name="">
             <a:extLst xmlns:a="http://schemas.openxmlformats.org/drawingml/2006/main">
               <a:ext uri="{FF2B5EF4-FFF2-40B4-BE49-F238E27FC236}">
-                <a16:creationId xmlns:a16="http://schemas.microsoft.com/office/drawing/2014/main" id="{4BE66A04-5881-4A9A-A557-0D74071DDC9A}"/>
+                <a16:creationId xmlns:a16="http://schemas.microsoft.com/office/drawing/2014/main" id="{33D13DCD-81B9-4F53-AEF8-8D007799247D}"/>
               </a:ext>
             </a:extLst>
           </p:cNvPr>
@@ -14891,7 +14891,7 @@
           <p:cNvPr id="2" name="">
             <a:extLst xmlns:a="http://schemas.openxmlformats.org/drawingml/2006/main">
               <a:ext uri="{FF2B5EF4-FFF2-40B4-BE49-F238E27FC236}">
-                <a16:creationId xmlns:a16="http://schemas.microsoft.com/office/drawing/2014/main" id="{5651E734-119F-4A26-A8B0-A152E12CEAD0}"/>
+                <a16:creationId xmlns:a16="http://schemas.microsoft.com/office/drawing/2014/main" id="{A87DC8C5-2726-4AE8-99D9-6E106050D984}"/>
               </a:ext>
             </a:extLst>
           </p:cNvPr>
@@ -14922,7 +14922,7 @@
           <p:cNvPr id="3" name="">
             <a:extLst xmlns:a="http://schemas.openxmlformats.org/drawingml/2006/main">
               <a:ext uri="{FF2B5EF4-FFF2-40B4-BE49-F238E27FC236}">
-                <a16:creationId xmlns:a16="http://schemas.microsoft.com/office/drawing/2014/main" id="{ACA0CCC7-5ABF-47A0-A27C-7F3A79E8E1B6}"/>
+                <a16:creationId xmlns:a16="http://schemas.microsoft.com/office/drawing/2014/main" id="{3DDFB978-DAE0-4C5C-B0E8-E21384D066A2}"/>
               </a:ext>
             </a:extLst>
           </p:cNvPr>
@@ -15079,7 +15079,7 @@
           <p:cNvPr id="4" name="">
             <a:extLst xmlns:a="http://schemas.openxmlformats.org/drawingml/2006/main">
               <a:ext uri="{FF2B5EF4-FFF2-40B4-BE49-F238E27FC236}">
-                <a16:creationId xmlns:a16="http://schemas.microsoft.com/office/drawing/2014/main" id="{7CB4255B-2616-4732-A751-2D990307FA26}"/>
+                <a16:creationId xmlns:a16="http://schemas.microsoft.com/office/drawing/2014/main" id="{767539B1-E52A-43BF-B5B1-54B70DA8DEB6}"/>
               </a:ext>
             </a:extLst>
           </p:cNvPr>
@@ -16045,7 +16045,7 @@
           <p:cNvPr id="5" name="">
             <a:extLst xmlns:a="http://schemas.openxmlformats.org/drawingml/2006/main">
               <a:ext uri="{FF2B5EF4-FFF2-40B4-BE49-F238E27FC236}">
-                <a16:creationId xmlns:a16="http://schemas.microsoft.com/office/drawing/2014/main" id="{A456A095-E49F-4B3A-AECF-01644A7546F1}"/>
+                <a16:creationId xmlns:a16="http://schemas.microsoft.com/office/drawing/2014/main" id="{305E12BD-8EA7-49E2-A6FD-9F08EF55ACA7}"/>
               </a:ext>
             </a:extLst>
           </p:cNvPr>
@@ -16200,7 +16200,7 @@
     </p:spTree>
     <p:extLst>
       <p:ext uri="{BB962C8B-B14F-4D97-AF65-F5344CB8AC3E}">
-        <p14:creationId xmlns:p14="http://schemas.microsoft.com/office/powerpoint/2010/main" val="1889528487"/>
+        <p14:creationId xmlns:p14="http://schemas.microsoft.com/office/powerpoint/2010/main" val="1450398264"/>
       </p:ext>
     </p:extLst>
   </p:cSld>
@@ -16231,7 +16231,7 @@
           <p:cNvPr id="7" name="">
             <a:extLst xmlns:a="http://schemas.openxmlformats.org/drawingml/2006/main">
               <a:ext uri="{FF2B5EF4-FFF2-40B4-BE49-F238E27FC236}">
-                <a16:creationId xmlns:a16="http://schemas.microsoft.com/office/drawing/2014/main" id="{466AFB65-37FD-4F46-B325-0FDC538EBC03}"/>
+                <a16:creationId xmlns:a16="http://schemas.microsoft.com/office/drawing/2014/main" id="{84146A56-5AE3-47AC-A9C4-765762F042DE}"/>
               </a:ext>
             </a:extLst>
           </p:cNvPr>
@@ -16388,7 +16388,7 @@
           <p:cNvPr id="2" name="">
             <a:extLst xmlns:a="http://schemas.openxmlformats.org/drawingml/2006/main">
               <a:ext uri="{FF2B5EF4-FFF2-40B4-BE49-F238E27FC236}">
-                <a16:creationId xmlns:a16="http://schemas.microsoft.com/office/drawing/2014/main" id="{A158BF6D-BF19-4BDB-B624-2A2D7E7FD8E1}"/>
+                <a16:creationId xmlns:a16="http://schemas.microsoft.com/office/drawing/2014/main" id="{E5622447-164B-4FFA-8D96-1AABAE00B433}"/>
               </a:ext>
             </a:extLst>
           </p:cNvPr>
@@ -16419,7 +16419,7 @@
           <p:cNvPr id="3" name="">
             <a:extLst xmlns:a="http://schemas.openxmlformats.org/drawingml/2006/main">
               <a:ext uri="{FF2B5EF4-FFF2-40B4-BE49-F238E27FC236}">
-                <a16:creationId xmlns:a16="http://schemas.microsoft.com/office/drawing/2014/main" id="{95DEE651-AA53-433A-981F-378791E2A8EE}"/>
+                <a16:creationId xmlns:a16="http://schemas.microsoft.com/office/drawing/2014/main" id="{A1EF1ED3-EB8E-44D7-9823-652F419BAF0C}"/>
               </a:ext>
             </a:extLst>
           </p:cNvPr>
@@ -16576,7 +16576,7 @@
           <p:cNvPr id="4" name="">
             <a:extLst xmlns:a="http://schemas.openxmlformats.org/drawingml/2006/main">
               <a:ext uri="{FF2B5EF4-FFF2-40B4-BE49-F238E27FC236}">
-                <a16:creationId xmlns:a16="http://schemas.microsoft.com/office/drawing/2014/main" id="{F8BB36AF-613B-4CD6-A6BD-E8EB27175D59}"/>
+                <a16:creationId xmlns:a16="http://schemas.microsoft.com/office/drawing/2014/main" id="{E525C14C-CA57-4C9F-913C-C5C8A5EEF35C}"/>
               </a:ext>
             </a:extLst>
           </p:cNvPr>
@@ -17086,7 +17086,7 @@
           <p:cNvPr id="5" name="">
             <a:extLst xmlns:a="http://schemas.openxmlformats.org/drawingml/2006/main">
               <a:ext uri="{FF2B5EF4-FFF2-40B4-BE49-F238E27FC236}">
-                <a16:creationId xmlns:a16="http://schemas.microsoft.com/office/drawing/2014/main" id="{E138B9EC-919A-4C18-B372-1628AEEAE456}"/>
+                <a16:creationId xmlns:a16="http://schemas.microsoft.com/office/drawing/2014/main" id="{AB4B2D4F-F637-45AD-B2F8-9E48EDF04E26}"/>
               </a:ext>
             </a:extLst>
           </p:cNvPr>
@@ -17266,7 +17266,7 @@
           <p:cNvPr id="6" name="">
             <a:extLst xmlns:a="http://schemas.openxmlformats.org/drawingml/2006/main">
               <a:ext uri="{FF2B5EF4-FFF2-40B4-BE49-F238E27FC236}">
-                <a16:creationId xmlns:a16="http://schemas.microsoft.com/office/drawing/2014/main" id="{5CF6E8D9-20C3-4AF4-AA11-DB99E8D22F37}"/>
+                <a16:creationId xmlns:a16="http://schemas.microsoft.com/office/drawing/2014/main" id="{9447DC7C-E771-45F6-8371-03ADE20ABB50}"/>
               </a:ext>
             </a:extLst>
           </p:cNvPr>
@@ -17421,7 +17421,7 @@
     </p:spTree>
     <p:extLst>
       <p:ext uri="{BB962C8B-B14F-4D97-AF65-F5344CB8AC3E}">
-        <p14:creationId xmlns:p14="http://schemas.microsoft.com/office/powerpoint/2010/main" val="1123036446"/>
+        <p14:creationId xmlns:p14="http://schemas.microsoft.com/office/powerpoint/2010/main" val="785277141"/>
       </p:ext>
     </p:extLst>
   </p:cSld>

</xml_diff>